<commit_message>
Pitch: captura real del mapa en vivo y cifras medidas en ARM64
La diapositiva 3 mostraba el grafo estatico con el rotulo 'mapa en vivo': ahora es una captura real del mapa nuevo durante la ronda 3 contra el backend local (docs/mapa_en_vivo.png; se recorto el panel de metricas porque mide la laptop, no AWS). Resultados: 9.61/10 y p95 14 ms en ARM64 (CI). El A/B nombra cada barra por lo que quita y agrega 'Sin los 3 PRO' (6.47). Capacidad: -84 % (antes -82 %), con su costo en las notas del orador.
</commit_message>
<xml_diff>
--- a/docs/pitch.pptx
+++ b/docs/pitch.pptx
@@ -114,34 +114,34 @@
   <p:extLst>
     <p:ext uri="{521415D9-36F7-43E2-AB2F-B90AF26B5E84}">
       <p14:sectionLst xmlns:p14="http://schemas.microsoft.com/office/powerpoint/2010/main">
-        <p14:section name="Apertura" id="{9bc249b2-50da-f704-5b1e-4057a61683d8}">
+        <p14:section name="Apertura" id="{b6ce3d4f-4e1c-9710-0fbc-24f8ee90095f}">
           <p14:sldIdLst>
             <p14:sldId id="256"/>
           </p14:sldIdLst>
         </p14:section>
-        <p14:section name="Problema" id="{220747d6-f869-6a34-8286-c9ea5a9f2f9d}">
+        <p14:section name="Problema" id="{13acfd26-7338-2d4d-fcb8-4b0c530dae41}">
           <p14:sldIdLst>
             <p14:sldId id="257"/>
           </p14:sldIdLst>
         </p14:section>
-        <p14:section name="Solución" id="{cd2f2ab7-15a6-e715-0240-f5c22bd13ab2}">
+        <p14:section name="Solución" id="{c334b752-6421-05c9-6f80-aad5df9dfa87}">
           <p14:sldIdLst>
             <p14:sldId id="258"/>
             <p14:sldId id="259"/>
           </p14:sldIdLst>
         </p14:section>
-        <p14:section name="Resultados" id="{3afbdbee-b246-4948-b783-f8a317efe831}">
+        <p14:section name="Resultados" id="{75091893-371f-4258-8eb3-121a72afe20e}">
           <p14:sldIdLst>
             <p14:sldId id="260"/>
             <p14:sldId id="261"/>
           </p14:sldIdLst>
         </p14:section>
-        <p14:section name="AWS" id="{eb4a6141-7d7a-f58f-d3da-3d8deb476e62}">
+        <p14:section name="AWS" id="{0fb498be-3fa7-3559-d4a2-0b9b87c5bc11}">
           <p14:sldIdLst>
             <p14:sldId id="262"/>
           </p14:sldIdLst>
         </p14:section>
-        <p14:section name="Cierre" id="{69713a74-4c3a-4b1f-2b1c-a8ec3b535d9c}">
+        <p14:section name="Cierre" id="{a073a4e9-48f4-c04f-b49e-d610494147ec}">
           <p14:sldIdLst>
             <p14:sldId id="263"/>
           </p14:sldIdLst>
@@ -181,7 +181,7 @@
                 </a:solidFill>
                 <a:latin typeface="+mn-lt"/>
               </a:rPr>
-              <a:t>A/B del planner: supervivencia + eficiencia (de 7)</a:t>
+              <a:t>A/B: producción menos una pieza (de 7)</a:t>
             </a:r>
           </a:p>
         </c:rich>
@@ -291,6 +291,17 @@
             <c:bubble3D val="0"/>
             <c:spPr>
               <a:solidFill>
+                <a:srgbClr val="8B5CF6"/>
+              </a:solidFill>
+              <a:effectLst/>
+            </c:spPr>
+          </c:dPt>
+          <c:dPt>
+            <c:idx val="5"/>
+            <c:invertIfNegative val="0"/>
+            <c:bubble3D val="0"/>
+            <c:spPr>
+              <a:solidFill>
                 <a:srgbClr val="F6AD55"/>
               </a:solidFill>
               <a:effectLst/>
@@ -298,23 +309,26 @@
           </c:dPt>
           <c:cat>
             <c:multiLvlStrRef>
-              <c:f>Sheet1!$A$2:$A$6</c:f>
+              <c:f>Sheet1!$A$2:$A$7</c:f>
               <c:multiLvlStrCache>
-                <c:ptCount val="5"/>
+                <c:ptCount val="6"/>
                 <c:lvl>
                   <c:pt idx="0">
-                    <c:v>Base (sin PRO)</c:v>
+                    <c:v>Sin PRO ni costo por cruce</c:v>
                   </c:pt>
                   <c:pt idx="1">
-                    <c:v>Sin costo por intersección</c:v>
+                    <c:v>Sin costo por cruce</c:v>
                   </c:pt>
                   <c:pt idx="2">
+                    <c:v>Sin los 3 PRO</c:v>
+                  </c:pt>
+                  <c:pt idx="3">
                     <c:v>Sin flota</c:v>
                   </c:pt>
-                  <c:pt idx="3">
+                  <c:pt idx="4">
                     <c:v>Sin predicción</c:v>
                   </c:pt>
-                  <c:pt idx="4">
+                  <c:pt idx="5">
                     <c:v>Producción</c:v>
                   </c:pt>
                 </c:lvl>
@@ -323,10 +337,10 @@
           </c:cat>
           <c:val>
             <c:numRef>
-              <c:f>Sheet1!$B$2:$B$6</c:f>
+              <c:f>Sheet1!$B$2:$B$7</c:f>
               <c:numCache>
                 <c:formatCode>General</c:formatCode>
-                <c:ptCount val="5"/>
+                <c:ptCount val="6"/>
                 <c:pt idx="0">
                   <c:v>6.282</c:v>
                 </c:pt>
@@ -334,12 +348,15 @@
                   <c:v>6.339</c:v>
                 </c:pt>
                 <c:pt idx="2">
+                  <c:v>6.473</c:v>
+                </c:pt>
+                <c:pt idx="3">
                   <c:v>6.478</c:v>
                 </c:pt>
-                <c:pt idx="3">
+                <c:pt idx="4">
                   <c:v>6.502</c:v>
                 </c:pt>
-                <c:pt idx="4">
+                <c:pt idx="5">
                   <c:v>6.539</c:v>
                 </c:pt>
               </c:numCache>
@@ -1244,7 +1261,7 @@
           <a:p>
             <a:r>
               <a:rPr lang="en-US" dirty="0"/>
-              <a:t>Todo esto está medido. En la CI de GitHub levantamos el contenedor con la misma CPU que Fargate, 0.5 vCPU, y jugamos las 3 rondas por HTTP: 9.56 de 10, p95 de 20 ms con 200 a la vez y cero errores. A la derecha, el A/B: cada pieza del diseño suma, y la versión final es la mejor.</a:t>
+              <a:t>Todo esto está medido. En la CI de GitHub levantamos el contenedor en ARM64, como Graviton en Fargate, con 0.5 vCPU, y jugamos las 3 rondas por HTTP: 9.61 de 10, p95 de 14 ms con 200 a la vez y cero errores. A la derecha, el A/B: a la versión final le quitamos una pieza a la vez y siempre empeora; lo que más pesa es el costo por cruce, y los tres PRO juntos suman 0.07.</a:t>
             </a:r>
             <a:endParaRPr lang="en-US" dirty="0"/>
           </a:p>
@@ -1332,7 +1349,7 @@
           <a:p>
             <a:r>
               <a:rPr lang="en-US" dirty="0"/>
-              <a:t>Hicimos los tres extras y medimos cada uno en el mapa real. Predicción: replicamos la persecución del corredor y evitamos solo las trampas, no cualquier cercanía, porque alejarse de todo alarga las rutas y termina mordiendo más. Capacidad: repartimos según el cupo que tendrá cada refugio cuando llegues. Flota: cinco camionetas que el servidor despacha cada turno.</a:t>
+              <a:t>Hicimos los tres extras y medimos cada uno en el mapa real. Predicción: replicamos la persecución del corredor y evitamos solo las trampas, no cualquier cercanía, porque alejarse de todo alarga las rutas y termina mordiendo más. Capacidad: repartimos según el cupo que tendrá cada refugio cuando llegues. Tiene un costo que medimos: desviar a alguien a un refugio más lejano lo expone más y en la ronda 3 suben las mordidas; lo dejamos activo porque en una evacuación real un refugio lleno no es seguro. Flota: cinco camionetas que el servidor despacha cada turno.</a:t>
             </a:r>
             <a:endParaRPr lang="en-US" dirty="0"/>
           </a:p>
@@ -3817,7 +3834,7 @@
       </p:sp>
       <p:pic>
         <p:nvPicPr>
-          <p:cNvPr id="24" name="mapa_vivo" descr="Mapa en vivo con zombies, sobrevivientes, rutas y refugios">    </p:cNvPr>
+          <p:cNvPr id="24" name="mapa_vivo" descr="Mapa en vivo durante la ronda 3: zombies por tipo, zonas de horda, rutas, camionetas y refugios con su ocupación">    </p:cNvPr>
           <p:cNvPicPr>
             <a:picLocks noChangeAspect="1"/>
           </p:cNvPicPr>
@@ -3832,7 +3849,7 @@
         <p:spPr>
           <a:xfrm>
             <a:off x="7315200" y="1463040"/>
-            <a:ext cx="4206240" cy="2990088"/>
+            <a:ext cx="4206240" cy="3505200"/>
           </a:xfrm>
           <a:prstGeom prst="rect">
             <a:avLst/>
@@ -3847,8 +3864,8 @@
         </p:nvSpPr>
         <p:spPr>
           <a:xfrm>
-            <a:off x="7452360" y="4636008"/>
-            <a:ext cx="3931920" cy="1371600"/>
+            <a:off x="7452360" y="5105400"/>
+            <a:ext cx="3931920" cy="838200"/>
           </a:xfrm>
           <a:prstGeom prst="rect">
             <a:avLst/>
@@ -3864,7 +3881,7 @@
               <a:buNone/>
             </a:pPr>
             <a:r>
-              <a:rPr lang="en-US" sz="1500" dirty="0">
+              <a:rPr lang="en-US" sz="1400" dirty="0">
                 <a:solidFill>
                   <a:schemeClr val="bg2"/>
                 </a:solidFill>
@@ -3872,9 +3889,9 @@
                 <a:ea typeface="Calibri" pitchFamily="34" charset="-122"/>
                 <a:cs typeface="Calibri" pitchFamily="34" charset="-120"/>
               </a:rPr>
-              <a:t>Mapa en vivo: zombies por tipo, rutas planificadas, camionetas, cupos de refugios y puntaje en vivo. WebSocket con respaldo de polling.</a:t>
-            </a:r>
-            <a:endParaRPr lang="en-US" sz="1500" dirty="0"/>
+              <a:t>Captura real del mapa en vivo (ronda 3): zombies, hordas, rutas, camionetas y cupos de refugios.</a:t>
+            </a:r>
+            <a:endParaRPr lang="en-US" sz="1400" dirty="0"/>
           </a:p>
         </p:txBody>
       </p:sp>
@@ -4605,7 +4622,7 @@
                 <a:ea typeface="Bookman Old Style" pitchFamily="34" charset="-122"/>
                 <a:cs typeface="Bookman Old Style" pitchFamily="34" charset="-120"/>
               </a:rPr>
-              <a:t>9.56</a:t>
+              <a:t>9.61</a:t>
             </a:r>
             <a:endParaRPr lang="en-US" sz="4800" dirty="0"/>
           </a:p>
@@ -4644,7 +4661,7 @@
                 <a:ea typeface="Calibri" pitchFamily="34" charset="-122"/>
                 <a:cs typeface="Calibri" pitchFamily="34" charset="-120"/>
               </a:rPr>
-              <a:t>de 10 en la rúbrica: 3 rondas en un contenedor de 0.5 vCPU (CI)</a:t>
+              <a:t>de 10 en la rúbrica: 3 rondas en un contenedor ARM64 de 0.5 vCPU (CI)</a:t>
             </a:r>
             <a:endParaRPr lang="en-US" sz="1400" dirty="0"/>
           </a:p>
@@ -4683,7 +4700,7 @@
                 <a:ea typeface="Bookman Old Style" pitchFamily="34" charset="-122"/>
                 <a:cs typeface="Bookman Old Style" pitchFamily="34" charset="-120"/>
               </a:rPr>
-              <a:t>20 ms</a:t>
+              <a:t>14 ms</a:t>
             </a:r>
             <a:endParaRPr lang="en-US" sz="4800" dirty="0"/>
           </a:p>
@@ -4878,7 +4895,7 @@
                 <a:ea typeface="Calibri" pitchFamily="34" charset="-122"/>
                 <a:cs typeface="Calibri" pitchFamily="34" charset="-120"/>
               </a:rPr>
-              <a:t>supervivencia en la ronda 3: 200 a la vez, todos los zombies</a:t>
+              <a:t>supervivencia en la ronda 3 de 150 turnos: 200 a la vez, todos los zombies</a:t>
             </a:r>
             <a:endParaRPr lang="en-US" sz="1400" dirty="0"/>
           </a:p>
@@ -5457,7 +5474,7 @@
                 <a:ea typeface="Calibri" pitchFamily="34" charset="-122"/>
                 <a:cs typeface="Calibri" pitchFamily="34" charset="-120"/>
               </a:rPr>
-              <a:t>−82 % llegadas a refugios llenos (R2+R3)</a:t>
+              <a:t>−84 % llegadas a refugios llenos (R2+R3)</a:t>
             </a:r>
             <a:endParaRPr lang="en-US" sz="1600" dirty="0"/>
           </a:p>

</xml_diff>

<commit_message>
Pitch: rango de la rubrica en ARM64 y p95 con todo a la vez
9.54 de 10 (hasta 9.61 en dos corridas de la CI en ARM64) y p95 de 16 ms en R3 con 200 consultas internas, 200 externas y 30 visores a la vez, 0 % de errores. PDF reexportado (8 paginas, 4.6 MB).
</commit_message>
<xml_diff>
--- a/docs/pitch.pptx
+++ b/docs/pitch.pptx
@@ -114,34 +114,34 @@
   <p:extLst>
     <p:ext uri="{521415D9-36F7-43E2-AB2F-B90AF26B5E84}">
       <p14:sectionLst xmlns:p14="http://schemas.microsoft.com/office/powerpoint/2010/main">
-        <p14:section name="Apertura" id="{b6ce3d4f-4e1c-9710-0fbc-24f8ee90095f}">
+        <p14:section name="Apertura" id="{1d21d3b0-b33c-1fd4-ebc3-5728d14d8fdc}">
           <p14:sldIdLst>
             <p14:sldId id="256"/>
           </p14:sldIdLst>
         </p14:section>
-        <p14:section name="Problema" id="{13acfd26-7338-2d4d-fcb8-4b0c530dae41}">
+        <p14:section name="Problema" id="{8bf1d0c2-0700-005c-3dc8-d908e2588fa0}">
           <p14:sldIdLst>
             <p14:sldId id="257"/>
           </p14:sldIdLst>
         </p14:section>
-        <p14:section name="Solución" id="{c334b752-6421-05c9-6f80-aad5df9dfa87}">
+        <p14:section name="Solución" id="{c11c3cb2-7590-3506-081d-82288f7913df}">
           <p14:sldIdLst>
             <p14:sldId id="258"/>
             <p14:sldId id="259"/>
           </p14:sldIdLst>
         </p14:section>
-        <p14:section name="Resultados" id="{75091893-371f-4258-8eb3-121a72afe20e}">
+        <p14:section name="Resultados" id="{bdd249da-e46c-6957-d878-78295da2a589}">
           <p14:sldIdLst>
             <p14:sldId id="260"/>
             <p14:sldId id="261"/>
           </p14:sldIdLst>
         </p14:section>
-        <p14:section name="AWS" id="{0fb498be-3fa7-3559-d4a2-0b9b87c5bc11}">
+        <p14:section name="AWS" id="{05ea644d-2588-51e7-9a32-3d81861f1561}">
           <p14:sldIdLst>
             <p14:sldId id="262"/>
           </p14:sldIdLst>
         </p14:section>
-        <p14:section name="Cierre" id="{a073a4e9-48f4-c04f-b49e-d610494147ec}">
+        <p14:section name="Cierre" id="{e6a3b7fb-e545-4d34-3670-95d12f8102e4}">
           <p14:sldIdLst>
             <p14:sldId id="263"/>
           </p14:sldIdLst>
@@ -1261,7 +1261,7 @@
           <a:p>
             <a:r>
               <a:rPr lang="en-US" dirty="0"/>
-              <a:t>Todo esto está medido. En la CI de GitHub levantamos el contenedor en ARM64, como Graviton en Fargate, con 0.5 vCPU, y jugamos las 3 rondas por HTTP: 9.61 de 10, p95 de 14 ms con 200 a la vez y cero errores. A la derecha, el A/B: a la versión final le quitamos una pieza a la vez y siempre empeora; lo que más pesa es el costo por cruce, y los tres PRO juntos suman 0.07.</a:t>
+              <a:t>Todo esto está medido. En la CI de GitHub levantamos el contenedor en ARM64, como Graviton en Fargate, con 0.5 vCPU, y jugamos las 3 rondas por HTTP: entre 9.54 y 9.61 de 10. Y con todo a la vez, la ronda 3, 200 consultas externas y 30 visores del mapa, el p95 fue de 16 ms con cero errores. A la derecha, el A/B: a la versión final le quitamos una pieza a la vez y siempre empeora; lo que más pesa es el costo por cruce, y los tres PRO juntos suman 0.07.</a:t>
             </a:r>
             <a:endParaRPr lang="en-US" dirty="0"/>
           </a:p>
@@ -4622,7 +4622,7 @@
                 <a:ea typeface="Bookman Old Style" pitchFamily="34" charset="-122"/>
                 <a:cs typeface="Bookman Old Style" pitchFamily="34" charset="-120"/>
               </a:rPr>
-              <a:t>9.61</a:t>
+              <a:t>9.54</a:t>
             </a:r>
             <a:endParaRPr lang="en-US" sz="4800" dirty="0"/>
           </a:p>
@@ -4661,7 +4661,7 @@
                 <a:ea typeface="Calibri" pitchFamily="34" charset="-122"/>
                 <a:cs typeface="Calibri" pitchFamily="34" charset="-120"/>
               </a:rPr>
-              <a:t>de 10 en la rúbrica: 3 rondas en un contenedor ARM64 de 0.5 vCPU (CI)</a:t>
+              <a:t>de 10 en la rúbrica (hasta 9.61): 3 rondas en ARM64 con 0.5 vCPU (CI)</a:t>
             </a:r>
             <a:endParaRPr lang="en-US" sz="1400" dirty="0"/>
           </a:p>
@@ -4700,7 +4700,7 @@
                 <a:ea typeface="Bookman Old Style" pitchFamily="34" charset="-122"/>
                 <a:cs typeface="Bookman Old Style" pitchFamily="34" charset="-120"/>
               </a:rPr>
-              <a:t>14 ms</a:t>
+              <a:t>16 ms</a:t>
             </a:r>
             <a:endParaRPr lang="en-US" sz="4800" dirty="0"/>
           </a:p>
@@ -4739,7 +4739,7 @@
                 <a:ea typeface="Calibri" pitchFamily="34" charset="-122"/>
                 <a:cs typeface="Calibri" pitchFamily="34" charset="-120"/>
               </a:rPr>
-              <a:t>p95 de POST /paso en la ronda 3, 200 a la vez (umbral 150 ms)</a:t>
+              <a:t>p95 de POST /paso en R3 con 200 internos, 200 externos y 30 visores a la vez (umbral 150 ms)</a:t>
             </a:r>
             <a:endParaRPr lang="en-US" sz="1400" dirty="0"/>
           </a:p>

</xml_diff>

<commit_message>
Pitch: rango de 9 corridas de la CI
La diapositiva 5 usaba solo 2 corridas (9.54-9.61). Ahora: 9.48 como minimo y hasta 9.70 en las ultimas 9 corridas en ARM64 con 0.5 vCPU, igual en la nota del orador. PDF reexportado.
</commit_message>
<xml_diff>
--- a/docs/pitch.pptx
+++ b/docs/pitch.pptx
@@ -114,34 +114,34 @@
   <p:extLst>
     <p:ext uri="{521415D9-36F7-43E2-AB2F-B90AF26B5E84}">
       <p14:sectionLst xmlns:p14="http://schemas.microsoft.com/office/powerpoint/2010/main">
-        <p14:section name="Apertura" id="{1d21d3b0-b33c-1fd4-ebc3-5728d14d8fdc}">
+        <p14:section name="Apertura" id="{5dffcf32-da6b-6881-17fc-a2b4d5da8e2c}">
           <p14:sldIdLst>
             <p14:sldId id="256"/>
           </p14:sldIdLst>
         </p14:section>
-        <p14:section name="Problema" id="{8bf1d0c2-0700-005c-3dc8-d908e2588fa0}">
+        <p14:section name="Problema" id="{9dd0e355-0eec-0c66-c868-3aee7d5874bd}">
           <p14:sldIdLst>
             <p14:sldId id="257"/>
           </p14:sldIdLst>
         </p14:section>
-        <p14:section name="Solución" id="{c11c3cb2-7590-3506-081d-82288f7913df}">
+        <p14:section name="Solución" id="{0bcf1f6c-41f0-1d65-fcea-69dcf288af5d}">
           <p14:sldIdLst>
             <p14:sldId id="258"/>
             <p14:sldId id="259"/>
           </p14:sldIdLst>
         </p14:section>
-        <p14:section name="Resultados" id="{bdd249da-e46c-6957-d878-78295da2a589}">
+        <p14:section name="Resultados" id="{1f192347-80e5-bcdd-a361-84b49770118c}">
           <p14:sldIdLst>
             <p14:sldId id="260"/>
             <p14:sldId id="261"/>
           </p14:sldIdLst>
         </p14:section>
-        <p14:section name="AWS" id="{05ea644d-2588-51e7-9a32-3d81861f1561}">
+        <p14:section name="AWS" id="{65f0ac3e-d3af-38d0-4fc1-e35d02aa3841}">
           <p14:sldIdLst>
             <p14:sldId id="262"/>
           </p14:sldIdLst>
         </p14:section>
-        <p14:section name="Cierre" id="{e6a3b7fb-e545-4d34-3670-95d12f8102e4}">
+        <p14:section name="Cierre" id="{a0f0b0a8-77b6-98ed-4140-92aa8ef2aff9}">
           <p14:sldIdLst>
             <p14:sldId id="263"/>
           </p14:sldIdLst>
@@ -1261,7 +1261,7 @@
           <a:p>
             <a:r>
               <a:rPr lang="en-US" dirty="0"/>
-              <a:t>Todo esto está medido. En la CI de GitHub levantamos el contenedor en ARM64, como Graviton en Fargate, con 0.5 vCPU, y jugamos las 3 rondas por HTTP: entre 9.54 y 9.61 de 10. Y con todo a la vez, la ronda 3, 200 consultas externas y 30 visores del mapa, el p95 fue de 16 ms con cero errores. A la derecha, el A/B: a la versión final le quitamos una pieza a la vez y siempre empeora; lo que más pesa es el costo por cruce, y los tres PRO juntos suman 0.07.</a:t>
+              <a:t>Todo esto está medido. En la CI de GitHub levantamos el contenedor en ARM64, como Graviton en Fargate, con 0.5 vCPU, y jugamos las 3 rondas por HTTP: en 9 corridas, entre 9.48 y 9.70 de 10. Y con todo a la vez, la ronda 3, 200 consultas externas y 30 visores del mapa, el p95 fue de 16 ms con cero errores. A la derecha, el A/B: a la versión final le quitamos una pieza a la vez y siempre empeora; lo que más pesa es el costo por cruce, y los tres PRO juntos suman 0.07.</a:t>
             </a:r>
             <a:endParaRPr lang="en-US" dirty="0"/>
           </a:p>
@@ -4622,7 +4622,7 @@
                 <a:ea typeface="Bookman Old Style" pitchFamily="34" charset="-122"/>
                 <a:cs typeface="Bookman Old Style" pitchFamily="34" charset="-120"/>
               </a:rPr>
-              <a:t>9.54</a:t>
+              <a:t>9.48</a:t>
             </a:r>
             <a:endParaRPr lang="en-US" sz="4800" dirty="0"/>
           </a:p>
@@ -4661,7 +4661,7 @@
                 <a:ea typeface="Calibri" pitchFamily="34" charset="-122"/>
                 <a:cs typeface="Calibri" pitchFamily="34" charset="-120"/>
               </a:rPr>
-              <a:t>de 10 en la rúbrica (hasta 9.61): 3 rondas en ARM64 con 0.5 vCPU (CI)</a:t>
+              <a:t>de 10 como mínimo en 9 corridas de la CI (hasta 9.70), ARM64 con 0.5 vCPU</a:t>
             </a:r>
             <a:endParaRPr lang="en-US" sz="1400" dirty="0"/>
           </a:p>

</xml_diff>

<commit_message>
Pitch: diagrama de arquitectura actualizado en la diapositiva 7
La diapositiva 7 usa docs/arquitectura.png: se regenera el pitch para que el PDF entregable muestre la nota nueva (WebSocket probado, metricas opcionales).
</commit_message>
<xml_diff>
--- a/docs/pitch.pptx
+++ b/docs/pitch.pptx
@@ -114,34 +114,34 @@
   <p:extLst>
     <p:ext uri="{521415D9-36F7-43E2-AB2F-B90AF26B5E84}">
       <p14:sectionLst xmlns:p14="http://schemas.microsoft.com/office/powerpoint/2010/main">
-        <p14:section name="Apertura" id="{5dffcf32-da6b-6881-17fc-a2b4d5da8e2c}">
+        <p14:section name="Apertura" id="{68bae795-8cc1-dcfe-62bc-28103b7d739c}">
           <p14:sldIdLst>
             <p14:sldId id="256"/>
           </p14:sldIdLst>
         </p14:section>
-        <p14:section name="Problema" id="{9dd0e355-0eec-0c66-c868-3aee7d5874bd}">
+        <p14:section name="Problema" id="{ce040097-5472-e93a-3007-2d44e89cdc1c}">
           <p14:sldIdLst>
             <p14:sldId id="257"/>
           </p14:sldIdLst>
         </p14:section>
-        <p14:section name="Solución" id="{0bcf1f6c-41f0-1d65-fcea-69dcf288af5d}">
+        <p14:section name="Solución" id="{cb3955a1-bdc7-eba7-7e3e-cd5e6be597e0}">
           <p14:sldIdLst>
             <p14:sldId id="258"/>
             <p14:sldId id="259"/>
           </p14:sldIdLst>
         </p14:section>
-        <p14:section name="Resultados" id="{1f192347-80e5-bcdd-a361-84b49770118c}">
+        <p14:section name="Resultados" id="{b23b7cdb-9e6b-6245-c82a-ae85941b8cea}">
           <p14:sldIdLst>
             <p14:sldId id="260"/>
             <p14:sldId id="261"/>
           </p14:sldIdLst>
         </p14:section>
-        <p14:section name="AWS" id="{65f0ac3e-d3af-38d0-4fc1-e35d02aa3841}">
+        <p14:section name="AWS" id="{08d7728d-e147-bcdb-f048-ac67be9b4303}">
           <p14:sldIdLst>
             <p14:sldId id="262"/>
           </p14:sldIdLst>
         </p14:section>
-        <p14:section name="Cierre" id="{a0f0b0a8-77b6-98ed-4140-92aa8ef2aff9}">
+        <p14:section name="Cierre" id="{5d76507e-5fe3-0cc6-0772-e7b51957c777}">
           <p14:sldIdLst>
             <p14:sldId id="263"/>
           </p14:sldIdLst>

</xml_diff>

<commit_message>
Pitch: mediana de 20 corridas, p95 maximo y A/B remedido
Diapositiva 5: 9.6 de 10 como mediana de 20 corridas de la CI (rango 9.31-9.70; cada corrida es una partida distinta) y 17 ms como p95 maximo con todo a la vez. La barra Sin prediccion pasa a 6.49 (remedida). Diapositiva 3: 'unos milisegundos' y 'microsegundos' en vez de cifras puntuales que dependen de la maquina. PDF reexportado.
</commit_message>
<xml_diff>
--- a/docs/pitch.pptx
+++ b/docs/pitch.pptx
@@ -114,34 +114,34 @@
   <p:extLst>
     <p:ext uri="{521415D9-36F7-43E2-AB2F-B90AF26B5E84}">
       <p14:sectionLst xmlns:p14="http://schemas.microsoft.com/office/powerpoint/2010/main">
-        <p14:section name="Apertura" id="{68bae795-8cc1-dcfe-62bc-28103b7d739c}">
+        <p14:section name="Apertura" id="{34a5112d-95f4-db06-b3b9-e849fd80962e}">
           <p14:sldIdLst>
             <p14:sldId id="256"/>
           </p14:sldIdLst>
         </p14:section>
-        <p14:section name="Problema" id="{ce040097-5472-e93a-3007-2d44e89cdc1c}">
+        <p14:section name="Problema" id="{94885444-1aa6-b035-aabe-74dac903c775}">
           <p14:sldIdLst>
             <p14:sldId id="257"/>
           </p14:sldIdLst>
         </p14:section>
-        <p14:section name="Solución" id="{cb3955a1-bdc7-eba7-7e3e-cd5e6be597e0}">
+        <p14:section name="Solución" id="{42e46e09-8f3a-90ba-8233-98811207791d}">
           <p14:sldIdLst>
             <p14:sldId id="258"/>
             <p14:sldId id="259"/>
           </p14:sldIdLst>
         </p14:section>
-        <p14:section name="Resultados" id="{b23b7cdb-9e6b-6245-c82a-ae85941b8cea}">
+        <p14:section name="Resultados" id="{cf59b31b-7a2a-022f-e1d7-ce088a58b693}">
           <p14:sldIdLst>
             <p14:sldId id="260"/>
             <p14:sldId id="261"/>
           </p14:sldIdLst>
         </p14:section>
-        <p14:section name="AWS" id="{08d7728d-e147-bcdb-f048-ac67be9b4303}">
+        <p14:section name="AWS" id="{28449f6b-53b7-b96c-fa0b-7b54deac5c69}">
           <p14:sldIdLst>
             <p14:sldId id="262"/>
           </p14:sldIdLst>
         </p14:section>
-        <p14:section name="Cierre" id="{5d76507e-5fe3-0cc6-0772-e7b51957c777}">
+        <p14:section name="Cierre" id="{5f94ec93-3947-abf9-f76a-9597ae47d88b}">
           <p14:sldIdLst>
             <p14:sldId id="263"/>
           </p14:sldIdLst>
@@ -354,7 +354,7 @@
                   <c:v>6.478</c:v>
                 </c:pt>
                 <c:pt idx="4">
-                  <c:v>6.502</c:v>
+                  <c:v>6.492</c:v>
                 </c:pt>
                 <c:pt idx="5">
                   <c:v>6.539</c:v>
@@ -1261,7 +1261,7 @@
           <a:p>
             <a:r>
               <a:rPr lang="en-US" dirty="0"/>
-              <a:t>Todo esto está medido. En la CI de GitHub levantamos el contenedor en ARM64, como Graviton en Fargate, con 0.5 vCPU, y jugamos las 3 rondas por HTTP: en 9 corridas, entre 9.48 y 9.70 de 10. Y con todo a la vez, la ronda 3, 200 consultas externas y 30 visores del mapa, el p95 fue de 16 ms con cero errores. A la derecha, el A/B: a la versión final le quitamos una pieza a la vez y siempre empeora; lo que más pesa es el costo por cruce, y los tres PRO juntos suman 0.07.</a:t>
+              <a:t>Todo esto está medido. En la CI de GitHub levantamos el contenedor en ARM64, como Graviton en Fargate, con 0.5 vCPU, y jugamos las 3 rondas por HTTP: en 20 corridas la mediana es 9.6 de 10, con un rango de 9.31 a 9.70, porque cada corrida es una partida distinta. Y con todo a la vez, la ronda 3, 200 consultas externas y 30 visores del mapa, el p95 fue como máximo de 17 ms, con cero errores. A la derecha, el A/B: a la versión final le quitamos una pieza a la vez y siempre empeora; lo que más pesa es el costo por cruce, y los tres PRO juntos suman 0.07.</a:t>
             </a:r>
             <a:endParaRPr lang="en-US" dirty="0"/>
           </a:p>
@@ -3467,7 +3467,7 @@
                 <a:ea typeface="Calibri" pitchFamily="34" charset="-122"/>
                 <a:cs typeface="Calibri" pitchFamily="34" charset="-120"/>
               </a:rPr>
-              <a:t>4 Dijkstra inversos (uno por refugio) con los zombies del turno: ≈ 3 ms.</a:t>
+              <a:t>4 Dijkstra inversos (uno por refugio) con los zombies del turno: unos milisegundos.</a:t>
             </a:r>
             <a:endParaRPr lang="en-US" sz="1400" dirty="0"/>
           </a:p>
@@ -3633,7 +3633,7 @@
                 <a:ea typeface="Calibri" pitchFamily="34" charset="-122"/>
                 <a:cs typeface="Calibri" pitchFamily="34" charset="-120"/>
               </a:rPr>
-              <a:t>Cada respuesta solo consulta las tablas del turno: ≈ 3 µs de cálculo.</a:t>
+              <a:t>Cada respuesta solo consulta las tablas del turno: microsegundos de cálculo.</a:t>
             </a:r>
             <a:endParaRPr lang="en-US" sz="1400" dirty="0"/>
           </a:p>
@@ -4622,7 +4622,7 @@
                 <a:ea typeface="Bookman Old Style" pitchFamily="34" charset="-122"/>
                 <a:cs typeface="Bookman Old Style" pitchFamily="34" charset="-120"/>
               </a:rPr>
-              <a:t>9.48</a:t>
+              <a:t>9.6</a:t>
             </a:r>
             <a:endParaRPr lang="en-US" sz="4800" dirty="0"/>
           </a:p>
@@ -4661,7 +4661,7 @@
                 <a:ea typeface="Calibri" pitchFamily="34" charset="-122"/>
                 <a:cs typeface="Calibri" pitchFamily="34" charset="-120"/>
               </a:rPr>
-              <a:t>de 10 como mínimo en 9 corridas de la CI (hasta 9.70), ARM64 con 0.5 vCPU</a:t>
+              <a:t>de 10: mediana de 20 corridas de la CI (rango 9.31–9.70), ARM64 con 0.5 vCPU</a:t>
             </a:r>
             <a:endParaRPr lang="en-US" sz="1400" dirty="0"/>
           </a:p>
@@ -4700,7 +4700,7 @@
                 <a:ea typeface="Bookman Old Style" pitchFamily="34" charset="-122"/>
                 <a:cs typeface="Bookman Old Style" pitchFamily="34" charset="-120"/>
               </a:rPr>
-              <a:t>16 ms</a:t>
+              <a:t>17 ms</a:t>
             </a:r>
             <a:endParaRPr lang="en-US" sz="4800" dirty="0"/>
           </a:p>
@@ -4739,7 +4739,7 @@
                 <a:ea typeface="Calibri" pitchFamily="34" charset="-122"/>
                 <a:cs typeface="Calibri" pitchFamily="34" charset="-120"/>
               </a:rPr>
-              <a:t>p95 de POST /paso en R3 con 200 internos, 200 externos y 30 visores a la vez (umbral 150 ms)</a:t>
+              <a:t>p95 máximo de POST /paso en R3 con 200 internos, 200 externos y 30 visores a la vez (umbral 150 ms)</a:t>
             </a:r>
             <a:endParaRPr lang="en-US" sz="1400" dirty="0"/>
           </a:p>

</xml_diff>

<commit_message>
Pitch: diagrama de la diapositiva 7 con el mapa en index.html, css/ y js/
</commit_message>
<xml_diff>
--- a/docs/pitch.pptx
+++ b/docs/pitch.pptx
@@ -114,34 +114,34 @@
   <p:extLst>
     <p:ext uri="{521415D9-36F7-43E2-AB2F-B90AF26B5E84}">
       <p14:sectionLst xmlns:p14="http://schemas.microsoft.com/office/powerpoint/2010/main">
-        <p14:section name="Apertura" id="{34a5112d-95f4-db06-b3b9-e849fd80962e}">
+        <p14:section name="Apertura" id="{50ba50bf-1d8e-6ecd-0394-40cd96e8ece3}">
           <p14:sldIdLst>
             <p14:sldId id="256"/>
           </p14:sldIdLst>
         </p14:section>
-        <p14:section name="Problema" id="{94885444-1aa6-b035-aabe-74dac903c775}">
+        <p14:section name="Problema" id="{f4f3f22d-9095-0d01-2082-21546375db78}">
           <p14:sldIdLst>
             <p14:sldId id="257"/>
           </p14:sldIdLst>
         </p14:section>
-        <p14:section name="Solución" id="{42e46e09-8f3a-90ba-8233-98811207791d}">
+        <p14:section name="Solución" id="{9767feae-7b14-63b9-2533-a76a0d2f122c}">
           <p14:sldIdLst>
             <p14:sldId id="258"/>
             <p14:sldId id="259"/>
           </p14:sldIdLst>
         </p14:section>
-        <p14:section name="Resultados" id="{cf59b31b-7a2a-022f-e1d7-ce088a58b693}">
+        <p14:section name="Resultados" id="{501adf67-1625-9566-5441-96a9cf0d9bbd}">
           <p14:sldIdLst>
             <p14:sldId id="260"/>
             <p14:sldId id="261"/>
           </p14:sldIdLst>
         </p14:section>
-        <p14:section name="AWS" id="{28449f6b-53b7-b96c-fa0b-7b54deac5c69}">
+        <p14:section name="AWS" id="{8ec917ff-ceba-b127-6e1c-4e0121d2ecea}">
           <p14:sldIdLst>
             <p14:sldId id="262"/>
           </p14:sldIdLst>
         </p14:section>
-        <p14:section name="Cierre" id="{5f94ec93-3947-abf9-f76a-9597ae47d88b}">
+        <p14:section name="Cierre" id="{90d55ed0-6ba0-2241-0be1-6827cb64cddb}">
           <p14:sldIdLst>
             <p14:sldId id="263"/>
           </p14:sldIdLst>

</xml_diff>